<commit_message>
Creative Atelier 기획안: 진행도 · 기록 · 멤버십 사례 3종 1장 추가 (Peoria · ANS Explore · High Explorer Cards)
Co-Authored-By: Claude Sonnet 5.5 <noreply@anthropic.com>
Claude-Session: https://claude.ai/code/session_011BBjM7b8Q7Xhvjdp6vDPPC
</commit_message>
<xml_diff>
--- a/block/Creative_Atelier_기획안.pptx
+++ b/block/Creative_Atelier_기획안.pptx
@@ -28,6 +28,7 @@
     <p:sldId id="276" r:id="rId22"/>
     <p:sldId id="277" r:id="rId23"/>
     <p:sldId id="278" r:id="rId24"/>
+    <p:sldId id="280" r:id="rId31"/>
     <p:sldId id="279" r:id="rId25"/>
   </p:sldIdLst>
   <p:notesMasterIdLst>
@@ -29420,6 +29421,1346 @@
               <a:t>24</a:t>
             </a:fld>
             <a:endParaRPr lang="en-US"/>
+          </a:p>
+        </p:txBody>
+      </p:sp>
+    </p:spTree>
+  </p:cSld>
+  <p:clrMapOvr>
+    <a:masterClrMapping/>
+  </p:clrMapOvr>
+</p:sld>
+</file>
+
+<file path=ppt/slides/slide25.xml><?xml version="1.0" encoding="utf-8"?>
+<p:sld xmlns:a="http://schemas.openxmlformats.org/drawingml/2006/main" xmlns:p="http://schemas.openxmlformats.org/presentationml/2006/main" xmlns:r="http://schemas.openxmlformats.org/officeDocument/2006/relationships">
+  <p:cSld>
+    <p:spTree>
+      <p:nvGrpSpPr>
+        <p:cNvPr id="1" name=""/>
+        <p:cNvGrpSpPr/>
+        <p:nvPr/>
+      </p:nvGrpSpPr>
+      <p:grpSpPr/>
+      <p:sp>
+        <p:nvSpPr>
+          <p:cNvPr id="2" name="Title 1"/>
+          <p:cNvSpPr>
+            <a:spLocks noGrp="1"/>
+          </p:cNvSpPr>
+          <p:nvPr>
+            <p:ph type="title" idx="101"/>
+          </p:nvPr>
+        </p:nvSpPr>
+        <p:spPr/>
+        <p:txBody>
+          <a:bodyPr/>
+          <a:lstStyle/>
+          <a:p>
+            <a:r>
+              <a:t>사례 모음 보충 | 진행도 · 기록 · 멤버십 3종 추가</a:t>
+            </a:r>
+          </a:p>
+        </p:txBody>
+      </p:sp>
+      <p:sp>
+        <p:nvSpPr>
+          <p:cNvPr id="3" name="Text Placeholder 2"/>
+          <p:cNvSpPr>
+            <a:spLocks noGrp="1"/>
+          </p:cNvSpPr>
+          <p:nvPr>
+            <p:ph type="body" idx="102"/>
+          </p:nvPr>
+        </p:nvSpPr>
+        <p:spPr/>
+        <p:txBody>
+          <a:bodyPr/>
+          <a:lstStyle/>
+          <a:p>
+            <a:r>
+              <a:t>재방문을 만드는 구조 3가지 · 사진은 각 출처 페이지에서 가져온 참고용(저작권은 각 출처) · 링크는 작성 시점 확인</a:t>
+            </a:r>
+          </a:p>
+        </p:txBody>
+      </p:sp>
+      <p:sp>
+        <p:nvSpPr>
+          <p:cNvPr id="36" name="Slide Number Placeholder 0"/>
+          <p:cNvSpPr>
+            <a:spLocks noGrp="1"/>
+          </p:cNvSpPr>
+          <p:nvPr>
+            <p:ph type="sldNum" sz="quarter" idx="4294967295"/>
+          </p:nvPr>
+        </p:nvSpPr>
+        <p:spPr>
+          <a:xfrm>
+            <a:off x="11064240" y="6419088"/>
+            <a:ext cx="640080" cy="274320"/>
+          </a:xfrm>
+          <a:prstGeom prst="rect">
+            <a:avLst/>
+          </a:prstGeom>
+          <a:extLst>
+            <a:ext uri="{C572A759-6A51-4108-AA02-DFA0A04FC94B}">
+              <ma14:wrappingTextBoxFlag xmlns:ma14="http://schemas.microsoft.com/office/mac/drawingml/2011/main" val="0"/>
+            </a:ext>
+          </a:extLst>
+        </p:spPr>
+        <p:txBody>
+          <a:bodyPr/>
+          <a:lstStyle>
+            <a:lvl1pPr>
+              <a:defRPr sz="1000">
+                <a:solidFill>
+                  <a:srgbClr val="5A5A5A"/>
+                </a:solidFill>
+              </a:defRPr>
+            </a:lvl1pPr>
+          </a:lstStyle>
+          <a:p>
+            <a:pPr algn="r"/>
+            <a:fld id="{F7021451-1387-4CA6-816F-3879F97B5CBC}" type="slidenum">
+              <a:rPr b="0" lang="en-US"/>
+              <a:t>23</a:t>
+            </a:fld>
+            <a:endParaRPr lang="en-US"/>
+          </a:p>
+        </p:txBody>
+      </p:sp>
+      <p:sp>
+        <p:nvSpPr>
+          <p:cNvPr id="37" name="Rounded Rectangle 36"/>
+          <p:cNvSpPr/>
+          <p:nvPr/>
+        </p:nvSpPr>
+        <p:spPr>
+          <a:xfrm>
+            <a:off x="548640" y="1783080"/>
+            <a:ext cx="3566160" cy="4526280"/>
+          </a:xfrm>
+          <a:prstGeom prst="roundRect">
+            <a:avLst>
+              <a:gd name="adj" fmla="val 3000"/>
+            </a:avLst>
+          </a:prstGeom>
+          <a:solidFill>
+            <a:srgbClr val="FFFFFF"/>
+          </a:solidFill>
+          <a:ln w="12700">
+            <a:solidFill>
+              <a:srgbClr val="D6D6D6"/>
+            </a:solidFill>
+          </a:ln>
+          <a:effectLst/>
+        </p:spPr>
+        <p:style>
+          <a:lnRef idx="1">
+            <a:schemeClr val="accent1"/>
+          </a:lnRef>
+          <a:fillRef idx="3">
+            <a:schemeClr val="accent1"/>
+          </a:fillRef>
+          <a:effectRef idx="2">
+            <a:schemeClr val="accent1"/>
+          </a:effectRef>
+          <a:fontRef idx="minor">
+            <a:schemeClr val="lt1"/>
+          </a:fontRef>
+        </p:style>
+        <p:txBody>
+          <a:bodyPr rtlCol="0" anchor="ctr"/>
+          <a:lstStyle/>
+          <a:p>
+            <a:pPr algn="ctr"/>
+          </a:p>
+        </p:txBody>
+      </p:sp>
+      <p:pic>
+        <p:nvPicPr>
+          <p:cNvPr id="38" name="Picture 37" descr="peoria_c.jpg"/>
+          <p:cNvPicPr>
+            <a:picLocks noChangeAspect="1"/>
+          </p:cNvPicPr>
+          <p:nvPr/>
+        </p:nvPicPr>
+        <p:blipFill>
+          <a:blip r:embed="rId2"/>
+          <a:stretch>
+            <a:fillRect/>
+          </a:stretch>
+        </p:blipFill>
+        <p:spPr>
+          <a:xfrm>
+            <a:off x="640080" y="1874519"/>
+            <a:ext cx="3383280" cy="1783080"/>
+          </a:xfrm>
+          <a:prstGeom prst="rect">
+            <a:avLst/>
+          </a:prstGeom>
+        </p:spPr>
+      </p:pic>
+      <p:sp>
+        <p:nvSpPr>
+          <p:cNvPr id="39" name="Rounded Rectangle 38"/>
+          <p:cNvSpPr/>
+          <p:nvPr/>
+        </p:nvSpPr>
+        <p:spPr>
+          <a:xfrm>
+            <a:off x="731520" y="3749039"/>
+            <a:ext cx="1280160" cy="237744"/>
+          </a:xfrm>
+          <a:prstGeom prst="roundRect">
+            <a:avLst/>
+          </a:prstGeom>
+          <a:solidFill>
+            <a:srgbClr val="0065B2"/>
+          </a:solidFill>
+          <a:ln>
+            <a:noFill/>
+          </a:ln>
+          <a:effectLst/>
+        </p:spPr>
+        <p:style>
+          <a:lnRef idx="1">
+            <a:schemeClr val="accent1"/>
+          </a:lnRef>
+          <a:fillRef idx="3">
+            <a:schemeClr val="accent1"/>
+          </a:fillRef>
+          <a:effectRef idx="2">
+            <a:schemeClr val="accent1"/>
+          </a:effectRef>
+          <a:fontRef idx="minor">
+            <a:schemeClr val="lt1"/>
+          </a:fontRef>
+        </p:style>
+        <p:txBody>
+          <a:bodyPr rtlCol="0" anchor="ctr" lIns="0" rIns="0" tIns="0" bIns="0"/>
+          <a:lstStyle/>
+          <a:p>
+            <a:pPr algn="ctr"/>
+            <a:r>
+              <a:rPr sz="1000" b="1">
+                <a:solidFill>
+                  <a:srgbClr val="FFFFFF"/>
+                </a:solidFill>
+                <a:latin typeface="Malgun Gothic"/>
+              </a:rPr>
+              <a:t>진행도 · 멤버십</a:t>
+            </a:r>
+          </a:p>
+        </p:txBody>
+      </p:sp>
+      <p:sp>
+        <p:nvSpPr>
+          <p:cNvPr id="40" name="TextBox 39"/>
+          <p:cNvSpPr txBox="1"/>
+          <p:nvPr/>
+        </p:nvSpPr>
+        <p:spPr>
+          <a:xfrm>
+            <a:off x="731520" y="4050791"/>
+            <a:ext cx="3200400" cy="457200"/>
+          </a:xfrm>
+          <a:prstGeom prst="rect">
+            <a:avLst/>
+          </a:prstGeom>
+          <a:noFill/>
+        </p:spPr>
+        <p:txBody>
+          <a:bodyPr wrap="square" lIns="0" rIns="0" tIns="0" bIns="0" anchor="t">
+            <a:spAutoFit/>
+          </a:bodyPr>
+          <a:lstStyle/>
+          <a:p>
+            <a:pPr>
+              <a:spcAft>
+                <a:spcPts val="300"/>
+              </a:spcAft>
+            </a:pPr>
+            <a:r>
+              <a:rPr sz="1150" b="1">
+                <a:solidFill>
+                  <a:srgbClr val="111111"/>
+                </a:solidFill>
+                <a:latin typeface="Malgun Gothic"/>
+              </a:rPr>
+              <a:t>Peoria Riverfront Museum · Achievement Passport</a:t>
+            </a:r>
+          </a:p>
+        </p:txBody>
+      </p:sp>
+      <p:sp>
+        <p:nvSpPr>
+          <p:cNvPr id="41" name="TextBox 40"/>
+          <p:cNvSpPr txBox="1"/>
+          <p:nvPr/>
+        </p:nvSpPr>
+        <p:spPr>
+          <a:xfrm>
+            <a:off x="731520" y="4480560"/>
+            <a:ext cx="3200400" cy="201168"/>
+          </a:xfrm>
+          <a:prstGeom prst="rect">
+            <a:avLst/>
+          </a:prstGeom>
+          <a:noFill/>
+        </p:spPr>
+        <p:txBody>
+          <a:bodyPr wrap="square" lIns="0" rIns="0" tIns="0" bIns="0" anchor="t">
+            <a:spAutoFit/>
+          </a:bodyPr>
+          <a:lstStyle/>
+          <a:p>
+            <a:pPr>
+              <a:spcAft>
+                <a:spcPts val="300"/>
+              </a:spcAft>
+            </a:pPr>
+            <a:r>
+              <a:rPr sz="900" b="1">
+                <a:solidFill>
+                  <a:srgbClr val="0065B2"/>
+                </a:solidFill>
+                <a:latin typeface="Malgun Gothic"/>
+              </a:rPr>
+              <a:t>미국 일리노이 · 무료 · 디지털 패스포트</a:t>
+            </a:r>
+          </a:p>
+        </p:txBody>
+      </p:sp>
+      <p:sp>
+        <p:nvSpPr>
+          <p:cNvPr id="42" name="TextBox 41"/>
+          <p:cNvSpPr txBox="1"/>
+          <p:nvPr/>
+        </p:nvSpPr>
+        <p:spPr>
+          <a:xfrm>
+            <a:off x="731520" y="4709160"/>
+            <a:ext cx="3200400" cy="914400"/>
+          </a:xfrm>
+          <a:prstGeom prst="rect">
+            <a:avLst/>
+          </a:prstGeom>
+          <a:noFill/>
+        </p:spPr>
+        <p:txBody>
+          <a:bodyPr wrap="square" lIns="0" rIns="0" tIns="0" bIns="0" anchor="t">
+            <a:spAutoFit/>
+          </a:bodyPr>
+          <a:lstStyle/>
+          <a:p>
+            <a:pPr>
+              <a:spcAft>
+                <a:spcPts val="300"/>
+              </a:spcAft>
+            </a:pPr>
+            <a:r>
+              <a:rPr sz="900" b="0">
+                <a:solidFill>
+                  <a:srgbClr val="111111"/>
+                </a:solidFill>
+                <a:latin typeface="Malgun Gothic"/>
+              </a:rPr>
+              <a:t>• 활동마다 점수(10–250점): 패스포트 QR을 스캔해 적립. 공작 25점, 투어 100점</a:t>
+            </a:r>
+          </a:p>
+          <a:p>
+            <a:pPr>
+              <a:spcAft>
+                <a:spcPts val="300"/>
+              </a:spcAft>
+            </a:pPr>
+            <a:r>
+              <a:rPr sz="900" b="0">
+                <a:solidFill>
+                  <a:srgbClr val="111111"/>
+                </a:solidFill>
+                <a:latin typeface="Malgun Gothic"/>
+              </a:rPr>
+              <a:t>• 회원은 해당 활동 점수 2배, 패스포트는 해마다 갱신</a:t>
+            </a:r>
+          </a:p>
+          <a:p>
+            <a:pPr>
+              <a:spcAft>
+                <a:spcPts val="300"/>
+              </a:spcAft>
+            </a:pPr>
+            <a:r>
+              <a:rPr sz="900" b="0">
+                <a:solidFill>
+                  <a:srgbClr val="111111"/>
+                </a:solidFill>
+                <a:latin typeface="Malgun Gothic"/>
+              </a:rPr>
+              <a:t>• 월간 · 연간 상품(성인/청소년 부문), 매월 2번째 일요일 100점 모으면 한정 핀</a:t>
+            </a:r>
+          </a:p>
+        </p:txBody>
+      </p:sp>
+      <p:sp>
+        <p:nvSpPr>
+          <p:cNvPr id="43" name="Rectangle 42"/>
+          <p:cNvSpPr/>
+          <p:nvPr/>
+        </p:nvSpPr>
+        <p:spPr>
+          <a:xfrm>
+            <a:off x="685800" y="5532120"/>
+            <a:ext cx="3291840" cy="475488"/>
+          </a:xfrm>
+          <a:prstGeom prst="rect">
+            <a:avLst/>
+          </a:prstGeom>
+          <a:solidFill>
+            <a:srgbClr val="F6F6F4"/>
+          </a:solidFill>
+          <a:ln>
+            <a:noFill/>
+          </a:ln>
+          <a:effectLst/>
+        </p:spPr>
+        <p:style>
+          <a:lnRef idx="1">
+            <a:schemeClr val="accent1"/>
+          </a:lnRef>
+          <a:fillRef idx="3">
+            <a:schemeClr val="accent1"/>
+          </a:fillRef>
+          <a:effectRef idx="2">
+            <a:schemeClr val="accent1"/>
+          </a:effectRef>
+          <a:fontRef idx="minor">
+            <a:schemeClr val="lt1"/>
+          </a:fontRef>
+        </p:style>
+        <p:txBody>
+          <a:bodyPr rtlCol="0" anchor="ctr"/>
+          <a:lstStyle/>
+          <a:p>
+            <a:pPr algn="ctr"/>
+          </a:p>
+        </p:txBody>
+      </p:sp>
+      <p:sp>
+        <p:nvSpPr>
+          <p:cNvPr id="44" name="TextBox 43"/>
+          <p:cNvSpPr txBox="1"/>
+          <p:nvPr/>
+        </p:nvSpPr>
+        <p:spPr>
+          <a:xfrm>
+            <a:off x="777240" y="5550408"/>
+            <a:ext cx="3108960" cy="438912"/>
+          </a:xfrm>
+          <a:prstGeom prst="rect">
+            <a:avLst/>
+          </a:prstGeom>
+          <a:noFill/>
+        </p:spPr>
+        <p:txBody>
+          <a:bodyPr wrap="square" lIns="0" rIns="0" tIns="0" bIns="0" anchor="ctr">
+            <a:spAutoFit/>
+          </a:bodyPr>
+          <a:lstStyle/>
+          <a:p>
+            <a:pPr>
+              <a:spcAft>
+                <a:spcPts val="300"/>
+              </a:spcAft>
+            </a:pPr>
+            <a:r>
+              <a:rPr sz="850" b="0">
+                <a:solidFill>
+                  <a:srgbClr val="111111"/>
+                </a:solidFill>
+                <a:latin typeface="Malgun Gothic"/>
+              </a:rPr>
+              <a:t>공방 적용(제안): ‘도감 · 시리즈’에 점수 + 회원 2배 가속을 붙이는 방식. 점수 값은 그 박물관 기준</a:t>
+            </a:r>
+          </a:p>
+        </p:txBody>
+      </p:sp>
+      <p:sp>
+        <p:nvSpPr>
+          <p:cNvPr id="45" name="TextBox 44"/>
+          <p:cNvSpPr txBox="1"/>
+          <p:nvPr/>
+        </p:nvSpPr>
+        <p:spPr>
+          <a:xfrm>
+            <a:off x="731520" y="6080760"/>
+            <a:ext cx="3200400" cy="182880"/>
+          </a:xfrm>
+          <a:prstGeom prst="rect">
+            <a:avLst/>
+          </a:prstGeom>
+          <a:noFill/>
+        </p:spPr>
+        <p:txBody>
+          <a:bodyPr wrap="square" lIns="0" rIns="0" tIns="0" bIns="0" anchor="t">
+            <a:spAutoFit/>
+          </a:bodyPr>
+          <a:lstStyle/>
+          <a:p>
+            <a:pPr>
+              <a:spcAft>
+                <a:spcPts val="300"/>
+              </a:spcAft>
+            </a:pPr>
+            <a:r>
+              <a:rPr sz="850" b="0" u="sng">
+                <a:solidFill>
+                  <a:srgbClr val="0065B2"/>
+                </a:solidFill>
+                <a:latin typeface="Malgun Gothic"/>
+                <a:hlinkClick r:id="rId3"/>
+              </a:rPr>
+              <a:t>출처: Peoria Riverfront Museum</a:t>
+            </a:r>
+          </a:p>
+        </p:txBody>
+      </p:sp>
+      <p:sp>
+        <p:nvSpPr>
+          <p:cNvPr id="46" name="Rounded Rectangle 45"/>
+          <p:cNvSpPr/>
+          <p:nvPr/>
+        </p:nvSpPr>
+        <p:spPr>
+          <a:xfrm>
+            <a:off x="4297679" y="1783080"/>
+            <a:ext cx="3566160" cy="4526280"/>
+          </a:xfrm>
+          <a:prstGeom prst="roundRect">
+            <a:avLst>
+              <a:gd name="adj" fmla="val 3000"/>
+            </a:avLst>
+          </a:prstGeom>
+          <a:solidFill>
+            <a:srgbClr val="FFFFFF"/>
+          </a:solidFill>
+          <a:ln w="12700">
+            <a:solidFill>
+              <a:srgbClr val="D6D6D6"/>
+            </a:solidFill>
+          </a:ln>
+          <a:effectLst/>
+        </p:spPr>
+        <p:style>
+          <a:lnRef idx="1">
+            <a:schemeClr val="accent1"/>
+          </a:lnRef>
+          <a:fillRef idx="3">
+            <a:schemeClr val="accent1"/>
+          </a:fillRef>
+          <a:effectRef idx="2">
+            <a:schemeClr val="accent1"/>
+          </a:effectRef>
+          <a:fontRef idx="minor">
+            <a:schemeClr val="lt1"/>
+          </a:fontRef>
+        </p:style>
+        <p:txBody>
+          <a:bodyPr rtlCol="0" anchor="ctr"/>
+          <a:lstStyle/>
+          <a:p>
+            <a:pPr algn="ctr"/>
+          </a:p>
+        </p:txBody>
+      </p:sp>
+      <p:pic>
+        <p:nvPicPr>
+          <p:cNvPr id="47" name="Picture 46" descr="ans_c.jpg"/>
+          <p:cNvPicPr>
+            <a:picLocks noChangeAspect="1"/>
+          </p:cNvPicPr>
+          <p:nvPr/>
+        </p:nvPicPr>
+        <p:blipFill>
+          <a:blip r:embed="rId4"/>
+          <a:stretch>
+            <a:fillRect/>
+          </a:stretch>
+        </p:blipFill>
+        <p:spPr>
+          <a:xfrm>
+            <a:off x="4389119" y="1874519"/>
+            <a:ext cx="3383280" cy="1783080"/>
+          </a:xfrm>
+          <a:prstGeom prst="rect">
+            <a:avLst/>
+          </a:prstGeom>
+        </p:spPr>
+      </p:pic>
+      <p:sp>
+        <p:nvSpPr>
+          <p:cNvPr id="48" name="Rounded Rectangle 47"/>
+          <p:cNvSpPr/>
+          <p:nvPr/>
+        </p:nvSpPr>
+        <p:spPr>
+          <a:xfrm>
+            <a:off x="4480559" y="3749039"/>
+            <a:ext cx="1280160" cy="237744"/>
+          </a:xfrm>
+          <a:prstGeom prst="roundRect">
+            <a:avLst/>
+          </a:prstGeom>
+          <a:solidFill>
+            <a:srgbClr val="FF8000"/>
+          </a:solidFill>
+          <a:ln>
+            <a:noFill/>
+          </a:ln>
+          <a:effectLst/>
+        </p:spPr>
+        <p:style>
+          <a:lnRef idx="1">
+            <a:schemeClr val="accent1"/>
+          </a:lnRef>
+          <a:fillRef idx="3">
+            <a:schemeClr val="accent1"/>
+          </a:fillRef>
+          <a:effectRef idx="2">
+            <a:schemeClr val="accent1"/>
+          </a:effectRef>
+          <a:fontRef idx="minor">
+            <a:schemeClr val="lt1"/>
+          </a:fontRef>
+        </p:style>
+        <p:txBody>
+          <a:bodyPr rtlCol="0" anchor="ctr" lIns="0" rIns="0" tIns="0" bIns="0"/>
+          <a:lstStyle/>
+          <a:p>
+            <a:pPr algn="ctr"/>
+            <a:r>
+              <a:rPr sz="1000" b="1">
+                <a:solidFill>
+                  <a:srgbClr val="FFFFFF"/>
+                </a:solidFill>
+                <a:latin typeface="Malgun Gothic"/>
+              </a:rPr>
+              <a:t>기록 · 수집</a:t>
+            </a:r>
+          </a:p>
+        </p:txBody>
+      </p:sp>
+      <p:sp>
+        <p:nvSpPr>
+          <p:cNvPr id="49" name="TextBox 48"/>
+          <p:cNvSpPr txBox="1"/>
+          <p:nvPr/>
+        </p:nvSpPr>
+        <p:spPr>
+          <a:xfrm>
+            <a:off x="4480559" y="4050791"/>
+            <a:ext cx="3200400" cy="457200"/>
+          </a:xfrm>
+          <a:prstGeom prst="rect">
+            <a:avLst/>
+          </a:prstGeom>
+          <a:noFill/>
+        </p:spPr>
+        <p:txBody>
+          <a:bodyPr wrap="square" lIns="0" rIns="0" tIns="0" bIns="0" anchor="t">
+            <a:spAutoFit/>
+          </a:bodyPr>
+          <a:lstStyle/>
+          <a:p>
+            <a:pPr>
+              <a:spcAft>
+                <a:spcPts val="300"/>
+              </a:spcAft>
+            </a:pPr>
+            <a:r>
+              <a:rPr sz="1150" b="1">
+                <a:solidFill>
+                  <a:srgbClr val="111111"/>
+                </a:solidFill>
+                <a:latin typeface="Malgun Gothic"/>
+              </a:rPr>
+              <a:t>ANS Explore! · Academy of Natural Sciences</a:t>
+            </a:r>
+          </a:p>
+        </p:txBody>
+      </p:sp>
+      <p:sp>
+        <p:nvSpPr>
+          <p:cNvPr id="50" name="TextBox 49"/>
+          <p:cNvSpPr txBox="1"/>
+          <p:nvPr/>
+        </p:nvSpPr>
+        <p:spPr>
+          <a:xfrm>
+            <a:off x="4480559" y="4480560"/>
+            <a:ext cx="3200400" cy="201168"/>
+          </a:xfrm>
+          <a:prstGeom prst="rect">
+            <a:avLst/>
+          </a:prstGeom>
+          <a:noFill/>
+        </p:spPr>
+        <p:txBody>
+          <a:bodyPr wrap="square" lIns="0" rIns="0" tIns="0" bIns="0" anchor="t">
+            <a:spAutoFit/>
+          </a:bodyPr>
+          <a:lstStyle/>
+          <a:p>
+            <a:pPr>
+              <a:spcAft>
+                <a:spcPts val="300"/>
+              </a:spcAft>
+            </a:pPr>
+            <a:r>
+              <a:rPr sz="900" b="1">
+                <a:solidFill>
+                  <a:srgbClr val="0065B2"/>
+                </a:solidFill>
+                <a:latin typeface="Malgun Gothic"/>
+              </a:rPr>
+              <a:t>미국 필라델피아 · 무료 앱(2013)</a:t>
+            </a:r>
+          </a:p>
+        </p:txBody>
+      </p:sp>
+      <p:sp>
+        <p:nvSpPr>
+          <p:cNvPr id="51" name="TextBox 50"/>
+          <p:cNvSpPr txBox="1"/>
+          <p:nvPr/>
+        </p:nvSpPr>
+        <p:spPr>
+          <a:xfrm>
+            <a:off x="4480559" y="4709160"/>
+            <a:ext cx="3200400" cy="914400"/>
+          </a:xfrm>
+          <a:prstGeom prst="rect">
+            <a:avLst/>
+          </a:prstGeom>
+          <a:noFill/>
+        </p:spPr>
+        <p:txBody>
+          <a:bodyPr wrap="square" lIns="0" rIns="0" tIns="0" bIns="0" anchor="t">
+            <a:spAutoFit/>
+          </a:bodyPr>
+          <a:lstStyle/>
+          <a:p>
+            <a:pPr>
+              <a:spcAft>
+                <a:spcPts val="300"/>
+              </a:spcAft>
+            </a:pPr>
+            <a:r>
+              <a:rPr sz="900" b="0">
+                <a:solidFill>
+                  <a:srgbClr val="111111"/>
+                </a:solidFill>
+                <a:latin typeface="Malgun Gothic"/>
+              </a:rPr>
+              <a:t>• 관람 중 QR 코드를 스캔해 배지를 모으는 가족용 스캐벤저 헌트 앱</a:t>
+            </a:r>
+          </a:p>
+          <a:p>
+            <a:pPr>
+              <a:spcAft>
+                <a:spcPts val="300"/>
+              </a:spcAft>
+            </a:pPr>
+            <a:r>
+              <a:rPr sz="900" b="0">
+                <a:solidFill>
+                  <a:srgbClr val="111111"/>
+                </a:solidFill>
+                <a:latin typeface="Malgun Gothic"/>
+              </a:rPr>
+              <a:t>• 테마는 ‘탈출한 나비 잡기’, 배지를 모으면 색칠 페이지 해금</a:t>
+            </a:r>
+          </a:p>
+          <a:p>
+            <a:pPr>
+              <a:spcAft>
+                <a:spcPts val="300"/>
+              </a:spcAft>
+            </a:pPr>
+            <a:r>
+              <a:rPr sz="900" b="0">
+                <a:solidFill>
+                  <a:srgbClr val="111111"/>
+                </a:solidFill>
+                <a:latin typeface="Malgun Gothic"/>
+              </a:rPr>
+              <a:t>• 지도로 4개 층 안내, Android · iOS 제공</a:t>
+            </a:r>
+          </a:p>
+        </p:txBody>
+      </p:sp>
+      <p:sp>
+        <p:nvSpPr>
+          <p:cNvPr id="52" name="Rectangle 51"/>
+          <p:cNvSpPr/>
+          <p:nvPr/>
+        </p:nvSpPr>
+        <p:spPr>
+          <a:xfrm>
+            <a:off x="4434840" y="5532120"/>
+            <a:ext cx="3291840" cy="475488"/>
+          </a:xfrm>
+          <a:prstGeom prst="rect">
+            <a:avLst/>
+          </a:prstGeom>
+          <a:solidFill>
+            <a:srgbClr val="F6F6F4"/>
+          </a:solidFill>
+          <a:ln>
+            <a:noFill/>
+          </a:ln>
+          <a:effectLst/>
+        </p:spPr>
+        <p:style>
+          <a:lnRef idx="1">
+            <a:schemeClr val="accent1"/>
+          </a:lnRef>
+          <a:fillRef idx="3">
+            <a:schemeClr val="accent1"/>
+          </a:fillRef>
+          <a:effectRef idx="2">
+            <a:schemeClr val="accent1"/>
+          </a:effectRef>
+          <a:fontRef idx="minor">
+            <a:schemeClr val="lt1"/>
+          </a:fontRef>
+        </p:style>
+        <p:txBody>
+          <a:bodyPr rtlCol="0" anchor="ctr"/>
+          <a:lstStyle/>
+          <a:p>
+            <a:pPr algn="ctr"/>
+          </a:p>
+        </p:txBody>
+      </p:sp>
+      <p:sp>
+        <p:nvSpPr>
+          <p:cNvPr id="53" name="TextBox 52"/>
+          <p:cNvSpPr txBox="1"/>
+          <p:nvPr/>
+        </p:nvSpPr>
+        <p:spPr>
+          <a:xfrm>
+            <a:off x="4526279" y="5550408"/>
+            <a:ext cx="3108960" cy="438912"/>
+          </a:xfrm>
+          <a:prstGeom prst="rect">
+            <a:avLst/>
+          </a:prstGeom>
+          <a:noFill/>
+        </p:spPr>
+        <p:txBody>
+          <a:bodyPr wrap="square" lIns="0" rIns="0" tIns="0" bIns="0" anchor="ctr">
+            <a:spAutoFit/>
+          </a:bodyPr>
+          <a:lstStyle/>
+          <a:p>
+            <a:pPr>
+              <a:spcAft>
+                <a:spcPts val="300"/>
+              </a:spcAft>
+            </a:pPr>
+            <a:r>
+              <a:rPr sz="850" b="0">
+                <a:solidFill>
+                  <a:srgbClr val="111111"/>
+                </a:solidFill>
+                <a:latin typeface="Malgun Gothic"/>
+              </a:rPr>
+              <a:t>공방 적용(제안): 작품 카드를 찍을 때마다 도감 한 칸이 채워지는 구조의 참고. 현재 운영 여부 · 연령은 확인 못 함(2013년 기사)</a:t>
+            </a:r>
+          </a:p>
+        </p:txBody>
+      </p:sp>
+      <p:sp>
+        <p:nvSpPr>
+          <p:cNvPr id="54" name="TextBox 53"/>
+          <p:cNvSpPr txBox="1"/>
+          <p:nvPr/>
+        </p:nvSpPr>
+        <p:spPr>
+          <a:xfrm>
+            <a:off x="4480559" y="6080760"/>
+            <a:ext cx="3200400" cy="182880"/>
+          </a:xfrm>
+          <a:prstGeom prst="rect">
+            <a:avLst/>
+          </a:prstGeom>
+          <a:noFill/>
+        </p:spPr>
+        <p:txBody>
+          <a:bodyPr wrap="square" lIns="0" rIns="0" tIns="0" bIns="0" anchor="t">
+            <a:spAutoFit/>
+          </a:bodyPr>
+          <a:lstStyle/>
+          <a:p>
+            <a:pPr>
+              <a:spcAft>
+                <a:spcPts val="300"/>
+              </a:spcAft>
+            </a:pPr>
+            <a:r>
+              <a:rPr sz="850" b="0" u="sng">
+                <a:solidFill>
+                  <a:srgbClr val="0065B2"/>
+                </a:solidFill>
+                <a:latin typeface="Malgun Gothic"/>
+                <a:hlinkClick r:id="rId5"/>
+              </a:rPr>
+              <a:t>출처: Drexel News (2013.8)</a:t>
+            </a:r>
+          </a:p>
+        </p:txBody>
+      </p:sp>
+      <p:sp>
+        <p:nvSpPr>
+          <p:cNvPr id="55" name="Rounded Rectangle 54"/>
+          <p:cNvSpPr/>
+          <p:nvPr/>
+        </p:nvSpPr>
+        <p:spPr>
+          <a:xfrm>
+            <a:off x="8046719" y="1783080"/>
+            <a:ext cx="3566160" cy="4526280"/>
+          </a:xfrm>
+          <a:prstGeom prst="roundRect">
+            <a:avLst>
+              <a:gd name="adj" fmla="val 3000"/>
+            </a:avLst>
+          </a:prstGeom>
+          <a:solidFill>
+            <a:srgbClr val="FFFFFF"/>
+          </a:solidFill>
+          <a:ln w="12700">
+            <a:solidFill>
+              <a:srgbClr val="D6D6D6"/>
+            </a:solidFill>
+          </a:ln>
+          <a:effectLst/>
+        </p:spPr>
+        <p:style>
+          <a:lnRef idx="1">
+            <a:schemeClr val="accent1"/>
+          </a:lnRef>
+          <a:fillRef idx="3">
+            <a:schemeClr val="accent1"/>
+          </a:fillRef>
+          <a:effectRef idx="2">
+            <a:schemeClr val="accent1"/>
+          </a:effectRef>
+          <a:fontRef idx="minor">
+            <a:schemeClr val="lt1"/>
+          </a:fontRef>
+        </p:style>
+        <p:txBody>
+          <a:bodyPr rtlCol="0" anchor="ctr"/>
+          <a:lstStyle/>
+          <a:p>
+            <a:pPr algn="ctr"/>
+          </a:p>
+        </p:txBody>
+      </p:sp>
+      <p:sp>
+        <p:nvSpPr>
+          <p:cNvPr id="56" name="Rectangle 55"/>
+          <p:cNvSpPr/>
+          <p:nvPr/>
+        </p:nvSpPr>
+        <p:spPr>
+          <a:xfrm>
+            <a:off x="8138159" y="1874519"/>
+            <a:ext cx="3383280" cy="1783080"/>
+          </a:xfrm>
+          <a:prstGeom prst="rect">
+            <a:avLst/>
+          </a:prstGeom>
+          <a:solidFill>
+            <a:srgbClr val="F6F6F4"/>
+          </a:solidFill>
+          <a:ln>
+            <a:solidFill>
+              <a:srgbClr val="D6D6D6"/>
+            </a:solidFill>
+            <a:prstDash val="dash"/>
+          </a:ln>
+          <a:effectLst/>
+        </p:spPr>
+        <p:style>
+          <a:lnRef idx="1">
+            <a:schemeClr val="accent1"/>
+          </a:lnRef>
+          <a:fillRef idx="3">
+            <a:schemeClr val="accent1"/>
+          </a:fillRef>
+          <a:effectRef idx="2">
+            <a:schemeClr val="accent1"/>
+          </a:effectRef>
+          <a:fontRef idx="minor">
+            <a:schemeClr val="lt1"/>
+          </a:fontRef>
+        </p:style>
+        <p:txBody>
+          <a:bodyPr rtlCol="0" anchor="ctr"/>
+          <a:lstStyle/>
+          <a:p>
+            <a:pPr algn="ctr"/>
+            <a:r>
+              <a:rPr sz="1200">
+                <a:solidFill>
+                  <a:srgbClr val="5A5A5A"/>
+                </a:solidFill>
+                <a:latin typeface="Malgun Gothic"/>
+              </a:rPr>
+              <a:t>카드 사진 확보 못 함</a:t>
+            </a:r>
+          </a:p>
+          <a:p>
+            <a:pPr algn="ctr"/>
+            <a:r>
+              <a:rPr sz="1200">
+                <a:solidFill>
+                  <a:srgbClr val="5A5A5A"/>
+                </a:solidFill>
+                <a:latin typeface="Malgun Gothic"/>
+              </a:rPr>
+              <a:t>출처 페이지 참고</a:t>
+            </a:r>
+          </a:p>
+        </p:txBody>
+      </p:sp>
+      <p:sp>
+        <p:nvSpPr>
+          <p:cNvPr id="57" name="Rounded Rectangle 56"/>
+          <p:cNvSpPr/>
+          <p:nvPr/>
+        </p:nvSpPr>
+        <p:spPr>
+          <a:xfrm>
+            <a:off x="8229599" y="3749039"/>
+            <a:ext cx="1280160" cy="237744"/>
+          </a:xfrm>
+          <a:prstGeom prst="roundRect">
+            <a:avLst/>
+          </a:prstGeom>
+          <a:solidFill>
+            <a:srgbClr val="00913B"/>
+          </a:solidFill>
+          <a:ln>
+            <a:noFill/>
+          </a:ln>
+          <a:effectLst/>
+        </p:spPr>
+        <p:style>
+          <a:lnRef idx="1">
+            <a:schemeClr val="accent1"/>
+          </a:lnRef>
+          <a:fillRef idx="3">
+            <a:schemeClr val="accent1"/>
+          </a:fillRef>
+          <a:effectRef idx="2">
+            <a:schemeClr val="accent1"/>
+          </a:effectRef>
+          <a:fontRef idx="minor">
+            <a:schemeClr val="lt1"/>
+          </a:fontRef>
+        </p:style>
+        <p:txBody>
+          <a:bodyPr rtlCol="0" anchor="ctr" lIns="0" rIns="0" tIns="0" bIns="0"/>
+          <a:lstStyle/>
+          <a:p>
+            <a:pPr algn="ctr"/>
+            <a:r>
+              <a:rPr sz="1000" b="1">
+                <a:solidFill>
+                  <a:srgbClr val="FFFFFF"/>
+                </a:solidFill>
+                <a:latin typeface="Malgun Gothic"/>
+              </a:rPr>
+              <a:t>월간 교체 · 기록</a:t>
+            </a:r>
+          </a:p>
+        </p:txBody>
+      </p:sp>
+      <p:sp>
+        <p:nvSpPr>
+          <p:cNvPr id="58" name="TextBox 57"/>
+          <p:cNvSpPr txBox="1"/>
+          <p:nvPr/>
+        </p:nvSpPr>
+        <p:spPr>
+          <a:xfrm>
+            <a:off x="8229599" y="4050791"/>
+            <a:ext cx="3200400" cy="457200"/>
+          </a:xfrm>
+          <a:prstGeom prst="rect">
+            <a:avLst/>
+          </a:prstGeom>
+          <a:noFill/>
+        </p:spPr>
+        <p:txBody>
+          <a:bodyPr wrap="square" lIns="0" rIns="0" tIns="0" bIns="0" anchor="t">
+            <a:spAutoFit/>
+          </a:bodyPr>
+          <a:lstStyle/>
+          <a:p>
+            <a:pPr>
+              <a:spcAft>
+                <a:spcPts val="300"/>
+              </a:spcAft>
+            </a:pPr>
+            <a:r>
+              <a:rPr sz="1150" b="1">
+                <a:solidFill>
+                  <a:srgbClr val="111111"/>
+                </a:solidFill>
+                <a:latin typeface="Malgun Gothic"/>
+              </a:rPr>
+              <a:t>High Museum of Art · Explorer Cards</a:t>
+            </a:r>
+          </a:p>
+        </p:txBody>
+      </p:sp>
+      <p:sp>
+        <p:nvSpPr>
+          <p:cNvPr id="59" name="TextBox 58"/>
+          <p:cNvSpPr txBox="1"/>
+          <p:nvPr/>
+        </p:nvSpPr>
+        <p:spPr>
+          <a:xfrm>
+            <a:off x="8229599" y="4480560"/>
+            <a:ext cx="3200400" cy="201168"/>
+          </a:xfrm>
+          <a:prstGeom prst="rect">
+            <a:avLst/>
+          </a:prstGeom>
+          <a:noFill/>
+        </p:spPr>
+        <p:txBody>
+          <a:bodyPr wrap="square" lIns="0" rIns="0" tIns="0" bIns="0" anchor="t">
+            <a:spAutoFit/>
+          </a:bodyPr>
+          <a:lstStyle/>
+          <a:p>
+            <a:pPr>
+              <a:spcAft>
+                <a:spcPts val="300"/>
+              </a:spcAft>
+            </a:pPr>
+            <a:r>
+              <a:rPr sz="900" b="1">
+                <a:solidFill>
+                  <a:srgbClr val="0065B2"/>
+                </a:solidFill>
+                <a:latin typeface="Malgun Gothic"/>
+              </a:rPr>
+              <a:t>미국 애틀랜타 · 무료 · 모든 연령</a:t>
+            </a:r>
+          </a:p>
+        </p:txBody>
+      </p:sp>
+      <p:sp>
+        <p:nvSpPr>
+          <p:cNvPr id="60" name="TextBox 59"/>
+          <p:cNvSpPr txBox="1"/>
+          <p:nvPr/>
+        </p:nvSpPr>
+        <p:spPr>
+          <a:xfrm>
+            <a:off x="8229599" y="4709160"/>
+            <a:ext cx="3200400" cy="914400"/>
+          </a:xfrm>
+          <a:prstGeom prst="rect">
+            <a:avLst/>
+          </a:prstGeom>
+          <a:noFill/>
+        </p:spPr>
+        <p:txBody>
+          <a:bodyPr wrap="square" lIns="0" rIns="0" tIns="0" bIns="0" anchor="t">
+            <a:spAutoFit/>
+          </a:bodyPr>
+          <a:lstStyle/>
+          <a:p>
+            <a:pPr>
+              <a:spcAft>
+                <a:spcPts val="300"/>
+              </a:spcAft>
+            </a:pPr>
+            <a:r>
+              <a:rPr sz="900" b="0">
+                <a:solidFill>
+                  <a:srgbClr val="111111"/>
+                </a:solidFill>
+                <a:latin typeface="Malgun Gothic"/>
+              </a:rPr>
+              <a:t>• 매월 초 새 카드: 전시 중 작품 하나를 골라 활동 제시</a:t>
+            </a:r>
+          </a:p>
+          <a:p>
+            <a:pPr>
+              <a:spcAft>
+                <a:spcPts val="300"/>
+              </a:spcAft>
+            </a:pPr>
+            <a:r>
+              <a:rPr sz="900" b="0">
+                <a:solidFill>
+                  <a:srgbClr val="111111"/>
+                </a:solidFill>
+                <a:latin typeface="Malgun Gothic"/>
+              </a:rPr>
+              <a:t>• 카드 뒷면 QR을 스캔해 등록 · 로그인 → 휴대폰 화면으로 숍에서 월간 상품 수령</a:t>
+            </a:r>
+          </a:p>
+          <a:p>
+            <a:pPr>
+              <a:spcAft>
+                <a:spcPts val="300"/>
+              </a:spcAft>
+            </a:pPr>
+            <a:r>
+              <a:rPr sz="900" b="0">
+                <a:solidFill>
+                  <a:srgbClr val="111111"/>
+                </a:solidFill>
+                <a:latin typeface="Malgun Gothic"/>
+              </a:rPr>
+              <a:t>• 로비 · 안내 데스크 · 숍에서 수령, 상품은 재고 한정</a:t>
+            </a:r>
+          </a:p>
+        </p:txBody>
+      </p:sp>
+      <p:sp>
+        <p:nvSpPr>
+          <p:cNvPr id="61" name="Rectangle 60"/>
+          <p:cNvSpPr/>
+          <p:nvPr/>
+        </p:nvSpPr>
+        <p:spPr>
+          <a:xfrm>
+            <a:off x="8183879" y="5532120"/>
+            <a:ext cx="3291840" cy="475488"/>
+          </a:xfrm>
+          <a:prstGeom prst="rect">
+            <a:avLst/>
+          </a:prstGeom>
+          <a:solidFill>
+            <a:srgbClr val="F6F6F4"/>
+          </a:solidFill>
+          <a:ln>
+            <a:noFill/>
+          </a:ln>
+          <a:effectLst/>
+        </p:spPr>
+        <p:style>
+          <a:lnRef idx="1">
+            <a:schemeClr val="accent1"/>
+          </a:lnRef>
+          <a:fillRef idx="3">
+            <a:schemeClr val="accent1"/>
+          </a:fillRef>
+          <a:effectRef idx="2">
+            <a:schemeClr val="accent1"/>
+          </a:effectRef>
+          <a:fontRef idx="minor">
+            <a:schemeClr val="lt1"/>
+          </a:fontRef>
+        </p:style>
+        <p:txBody>
+          <a:bodyPr rtlCol="0" anchor="ctr"/>
+          <a:lstStyle/>
+          <a:p>
+            <a:pPr algn="ctr"/>
+          </a:p>
+        </p:txBody>
+      </p:sp>
+      <p:sp>
+        <p:nvSpPr>
+          <p:cNvPr id="62" name="TextBox 61"/>
+          <p:cNvSpPr txBox="1"/>
+          <p:nvPr/>
+        </p:nvSpPr>
+        <p:spPr>
+          <a:xfrm>
+            <a:off x="8275319" y="5550408"/>
+            <a:ext cx="3108960" cy="438912"/>
+          </a:xfrm>
+          <a:prstGeom prst="rect">
+            <a:avLst/>
+          </a:prstGeom>
+          <a:noFill/>
+        </p:spPr>
+        <p:txBody>
+          <a:bodyPr wrap="square" lIns="0" rIns="0" tIns="0" bIns="0" anchor="ctr">
+            <a:spAutoFit/>
+          </a:bodyPr>
+          <a:lstStyle/>
+          <a:p>
+            <a:pPr>
+              <a:spcAft>
+                <a:spcPts val="300"/>
+              </a:spcAft>
+            </a:pPr>
+            <a:r>
+              <a:rPr sz="850" b="0">
+                <a:solidFill>
+                  <a:srgbClr val="111111"/>
+                </a:solidFill>
+                <a:latin typeface="Malgun Gothic"/>
+              </a:rPr>
+              <a:t>공방 적용(제안): ‘이번 달 프로젝트’ + 스캔 보상을 한 장 카드로 묶은 예. 상품 종류 · 이용 데이터는 확인 못 함</a:t>
+            </a:r>
+          </a:p>
+        </p:txBody>
+      </p:sp>
+      <p:sp>
+        <p:nvSpPr>
+          <p:cNvPr id="63" name="TextBox 62"/>
+          <p:cNvSpPr txBox="1"/>
+          <p:nvPr/>
+        </p:nvSpPr>
+        <p:spPr>
+          <a:xfrm>
+            <a:off x="8229599" y="6080760"/>
+            <a:ext cx="3200400" cy="182880"/>
+          </a:xfrm>
+          <a:prstGeom prst="rect">
+            <a:avLst/>
+          </a:prstGeom>
+          <a:noFill/>
+        </p:spPr>
+        <p:txBody>
+          <a:bodyPr wrap="square" lIns="0" rIns="0" tIns="0" bIns="0" anchor="t">
+            <a:spAutoFit/>
+          </a:bodyPr>
+          <a:lstStyle/>
+          <a:p>
+            <a:pPr>
+              <a:spcAft>
+                <a:spcPts val="300"/>
+              </a:spcAft>
+            </a:pPr>
+            <a:r>
+              <a:rPr sz="850" b="0" u="sng">
+                <a:solidFill>
+                  <a:srgbClr val="0065B2"/>
+                </a:solidFill>
+                <a:latin typeface="Malgun Gothic"/>
+                <a:hlinkClick r:id="rId6"/>
+              </a:rPr>
+              <a:t>출처: High Museum</a:t>
+            </a:r>
           </a:p>
         </p:txBody>
       </p:sp>

</xml_diff>